<commit_message>
fix: express §467 neighbor-relief as dollars, not a bare 5–65% range
The '5–65%' KPI read as opaque (range with no unit, no real-dollar
anchor). Now leads with ≈$4,700/yr — the 50%-tier relief on a ~$9.4K
school bill (est.) — with the why-it's-a-range stated plainly (income
sliding scale, 65% ≤$47K down to 5% at $58.4K → ≈$470–$6,100/home).
Applied in briefing p5, fiscal-math write-up (+sidebar +prose),
validation.html channel row, and PPTX slide 11.

Co-Authored-By: Claude Fable 5 <noreply@anthropic.com>
</commit_message>
<xml_diff>
--- a/site/RVC_Legislator_Deck.pptx
+++ b/site/RVC_Legislator_Deck.pptx
@@ -5926,7 +5926,7 @@
                 </a:solidFill>
                 <a:latin typeface="Georgia"/>
               </a:rPr>
-              <a:t>5–65</a:t>
+              <a:t>≈$4,700</a:t>
             </a:r>
             <a:r>
               <a:rPr sz="1600" b="0" i="1">
@@ -5935,7 +5935,7 @@
                 </a:solidFill>
                 <a:latin typeface="Georgia"/>
               </a:rPr>
-              <a:t> %</a:t>
+              <a:t> /yr</a:t>
             </a:r>
           </a:p>
         </p:txBody>
@@ -5974,7 +5974,7 @@
                 </a:solidFill>
                 <a:latin typeface="Arial"/>
               </a:rPr>
-              <a:t>A §467 parcel's school-tax share stops shifting onto every other taxpayer. The levy is fixed; exemptions move it around.</a:t>
+              <a:t>School tax un-shifted from neighbors at §467's 50% tier, on a ~$9.4K school bill (est.). It's a sliding scale by income — 65% (≤$47K) down to 5% ($58.4K) — so ≈$470–$6,100 per home. The levy is fixed; exemptions move it around.</a:t>
             </a:r>
           </a:p>
         </p:txBody>
@@ -6009,7 +6009,7 @@
                 </a:solidFill>
                 <a:latin typeface="Courier New"/>
               </a:rPr>
-              <a:t>OSC · NASSAU BROCHURE REV. 3-26</a:t>
+              <a:t>OSC · NASSAU BROCHURE · BILL ASSUMPTION LABELED</a:t>
             </a:r>
           </a:p>
         </p:txBody>

</xml_diff>

<commit_message>
fix: correct figures downstream of the $15,230 mislabel
- calculator: EFF_RATE 2.073% -> 2.57% (verified components), in-village
  COMPONENTS split, avgPropTax.rvc 15230 -> 21100, prose + chart, link
  to reconcile.html
- index/fiscal-math/deck: $4,700/yr section-467 card -> $7,300/yr on the
  verified ~$14.7K school bill (range $730-$9,500); deck rebuilt
- validation: correction-of-the-correction addendum (June's re-label of
  $15,230 as 'the total' was wrong; March's school-tax label was right)

Co-Authored-By: Claude Fable 5 <noreply@anthropic.com>
Claude-Session: https://claude.ai/code/session_012nybFVrVqVrRr2c3HDjvwE
</commit_message>
<xml_diff>
--- a/site/RVC_Legislator_Deck.pptx
+++ b/site/RVC_Legislator_Deck.pptx
@@ -5926,7 +5926,7 @@
                 </a:solidFill>
                 <a:latin typeface="Georgia"/>
               </a:rPr>
-              <a:t>≈$4,700</a:t>
+              <a:t>≈$7,300</a:t>
             </a:r>
             <a:r>
               <a:rPr sz="1600" b="0" i="1">
@@ -5974,7 +5974,7 @@
                 </a:solidFill>
                 <a:latin typeface="Arial"/>
               </a:rPr>
-              <a:t>School tax un-shifted from neighbors at §467's 50% tier, on a ~$9.4K school bill (est.). It's a sliding scale by income — 65% (≤$47K) down to 5% ($58.4K) — so ≈$470–$6,100 per home. The levy is fixed; exemptions move it around.</a:t>
+              <a:t>School tax un-shifted from neighbors at §467's 50% tier, on a verified ~$14.7K school bill. It's a sliding scale by income — 65% (≤$47K) down to 5% ($58.4K) — so ≈$730–$9,500 per home. The levy is fixed; exemptions move it around.</a:t>
             </a:r>
           </a:p>
         </p:txBody>
@@ -6009,7 +6009,7 @@
                 </a:solidFill>
                 <a:latin typeface="Courier New"/>
               </a:rPr>
-              <a:t>OSC · NASSAU BROCHURE · BILL ASSUMPTION LABELED</a:t>
+              <a:t>OSC · NASSAU BROCHURE · NASSAU LRV PARCEL TAX TABLE 2025-26</a:t>
             </a:r>
           </a:p>
         </p:txBody>

</xml_diff>